<commit_message>
Unit 6, uploaded notebooks
</commit_message>
<xml_diff>
--- a/Slides/unit_5_prog_2.pptx
+++ b/Slides/unit_5_prog_2.pptx
@@ -324,7 +324,7 @@
       </p15:sldGuideLst>
     </p:ext>
     <p:ext uri="http://customooxmlschemas.google.com/">
-      <go:slidesCustomData xmlns:go="http://customooxmlschemas.google.com/" xmlns:ahyp="http://schemas.microsoft.com/office/drawing/2018/hyperlinkcolor" xmlns:p15="http://schemas.microsoft.com/office/powerpoint/2012/main" xmlns:p14="http://schemas.microsoft.com/office/powerpoint/2010/main" xmlns:com="http://schemas.openxmlformats.org/drawingml/2006/compatibility" xmlns:pvml="urn:schemas-microsoft-com:office:powerpoint" xmlns:v="urn:schemas-microsoft-com:vml" xmlns:o="urn:schemas-microsoft-com:office:office" xmlns:dgm="http://schemas.openxmlformats.org/drawingml/2006/diagram" xmlns:c="http://schemas.openxmlformats.org/drawingml/2006/chart" xmlns:mv="urn:schemas-microsoft-com:mac:vml" xmlns:mc="http://schemas.openxmlformats.org/markup-compatibility/2006" xmlns="" r:id="rId80" roundtripDataSignature="AMtx7milieXwv5OUJdQk1cj/252aZuXcIQ=="/>
+      <go:slidesCustomData xmlns="" xmlns:mc="http://schemas.openxmlformats.org/markup-compatibility/2006" xmlns:mv="urn:schemas-microsoft-com:mac:vml" xmlns:c="http://schemas.openxmlformats.org/drawingml/2006/chart" xmlns:dgm="http://schemas.openxmlformats.org/drawingml/2006/diagram" xmlns:o="urn:schemas-microsoft-com:office:office" xmlns:v="urn:schemas-microsoft-com:vml" xmlns:pvml="urn:schemas-microsoft-com:office:powerpoint" xmlns:com="http://schemas.openxmlformats.org/drawingml/2006/compatibility" xmlns:p14="http://schemas.microsoft.com/office/powerpoint/2010/main" xmlns:p15="http://schemas.microsoft.com/office/powerpoint/2012/main" xmlns:ahyp="http://schemas.microsoft.com/office/drawing/2018/hyperlinkcolor" xmlns:go="http://customooxmlschemas.google.com/" r:id="rId80" roundtripDataSignature="AMtx7milieXwv5OUJdQk1cj/252aZuXcIQ=="/>
     </p:ext>
   </p:extLst>
 </p:presentation>
@@ -343,7 +343,7 @@
   <pc:docChgLst>
     <pc:chgData name="Ingo Frommholz" userId="ee3b4549-206f-4e4f-93a1-b7ff676f0af7" providerId="ADAL" clId="{5F8971C4-3D52-5FAB-A951-9912A46CDBB0}"/>
     <pc:docChg chg="undo custSel modSld">
-      <pc:chgData name="Ingo Frommholz" userId="ee3b4549-206f-4e4f-93a1-b7ff676f0af7" providerId="ADAL" clId="{5F8971C4-3D52-5FAB-A951-9912A46CDBB0}" dt="2025-10-29T15:04:46.856" v="221"/>
+      <pc:chgData name="Ingo Frommholz" userId="ee3b4549-206f-4e4f-93a1-b7ff676f0af7" providerId="ADAL" clId="{5F8971C4-3D52-5FAB-A951-9912A46CDBB0}" dt="2025-10-30T16:47:18.318" v="325" actId="20577"/>
       <pc:docMkLst>
         <pc:docMk/>
       </pc:docMkLst>
@@ -363,13 +363,13 @@
         </pc:spChg>
       </pc:sldChg>
       <pc:sldChg chg="modSp mod">
-        <pc:chgData name="Ingo Frommholz" userId="ee3b4549-206f-4e4f-93a1-b7ff676f0af7" providerId="ADAL" clId="{5F8971C4-3D52-5FAB-A951-9912A46CDBB0}" dt="2025-10-29T10:08:46.025" v="69" actId="20577"/>
+        <pc:chgData name="Ingo Frommholz" userId="ee3b4549-206f-4e4f-93a1-b7ff676f0af7" providerId="ADAL" clId="{5F8971C4-3D52-5FAB-A951-9912A46CDBB0}" dt="2025-10-30T16:47:18.318" v="325" actId="20577"/>
         <pc:sldMkLst>
           <pc:docMk/>
           <pc:sldMk cId="2965119385" sldId="468"/>
         </pc:sldMkLst>
         <pc:spChg chg="mod">
-          <ac:chgData name="Ingo Frommholz" userId="ee3b4549-206f-4e4f-93a1-b7ff676f0af7" providerId="ADAL" clId="{5F8971C4-3D52-5FAB-A951-9912A46CDBB0}" dt="2025-10-29T10:08:46.025" v="69" actId="20577"/>
+          <ac:chgData name="Ingo Frommholz" userId="ee3b4549-206f-4e4f-93a1-b7ff676f0af7" providerId="ADAL" clId="{5F8971C4-3D52-5FAB-A951-9912A46CDBB0}" dt="2025-10-30T16:47:18.318" v="325" actId="20577"/>
           <ac:spMkLst>
             <pc:docMk/>
             <pc:sldMk cId="2965119385" sldId="468"/>
@@ -408,13 +408,13 @@
         </pc:spChg>
       </pc:sldChg>
       <pc:sldChg chg="modSp mod">
-        <pc:chgData name="Ingo Frommholz" userId="ee3b4549-206f-4e4f-93a1-b7ff676f0af7" providerId="ADAL" clId="{5F8971C4-3D52-5FAB-A951-9912A46CDBB0}" dt="2025-10-29T09:46:40.570" v="2" actId="20577"/>
+        <pc:chgData name="Ingo Frommholz" userId="ee3b4549-206f-4e4f-93a1-b7ff676f0af7" providerId="ADAL" clId="{5F8971C4-3D52-5FAB-A951-9912A46CDBB0}" dt="2025-10-30T14:27:48.334" v="309" actId="20577"/>
         <pc:sldMkLst>
           <pc:docMk/>
           <pc:sldMk cId="255500345" sldId="501"/>
         </pc:sldMkLst>
         <pc:spChg chg="mod">
-          <ac:chgData name="Ingo Frommholz" userId="ee3b4549-206f-4e4f-93a1-b7ff676f0af7" providerId="ADAL" clId="{5F8971C4-3D52-5FAB-A951-9912A46CDBB0}" dt="2025-10-29T09:46:40.570" v="2" actId="20577"/>
+          <ac:chgData name="Ingo Frommholz" userId="ee3b4549-206f-4e4f-93a1-b7ff676f0af7" providerId="ADAL" clId="{5F8971C4-3D52-5FAB-A951-9912A46CDBB0}" dt="2025-10-30T14:27:48.334" v="309" actId="20577"/>
           <ac:spMkLst>
             <pc:docMk/>
             <pc:sldMk cId="255500345" sldId="501"/>
@@ -487,6 +487,21 @@
             <pc:docMk/>
             <pc:sldMk cId="1991990786" sldId="511"/>
             <ac:spMk id="8" creationId="{21A8D102-1C16-49D0-9B80-8EAB675A9A7B}"/>
+          </ac:spMkLst>
+        </pc:spChg>
+      </pc:sldChg>
+      <pc:sldChg chg="modSp mod">
+        <pc:chgData name="Ingo Frommholz" userId="ee3b4549-206f-4e4f-93a1-b7ff676f0af7" providerId="ADAL" clId="{5F8971C4-3D52-5FAB-A951-9912A46CDBB0}" dt="2025-10-30T15:33:18.903" v="323" actId="20577"/>
+        <pc:sldMkLst>
+          <pc:docMk/>
+          <pc:sldMk cId="2361308640" sldId="513"/>
+        </pc:sldMkLst>
+        <pc:spChg chg="mod">
+          <ac:chgData name="Ingo Frommholz" userId="ee3b4549-206f-4e4f-93a1-b7ff676f0af7" providerId="ADAL" clId="{5F8971C4-3D52-5FAB-A951-9912A46CDBB0}" dt="2025-10-30T15:33:18.903" v="323" actId="20577"/>
+          <ac:spMkLst>
+            <pc:docMk/>
+            <pc:sldMk cId="2361308640" sldId="513"/>
+            <ac:spMk id="6" creationId="{0804E025-6CC7-44C4-AD79-69A4EA4376F3}"/>
           </ac:spMkLst>
         </pc:spChg>
       </pc:sldChg>
@@ -28385,21 +28400,8 @@
                 <a:ea typeface="Cambria Math" panose="02040503050406030204" pitchFamily="18" charset="0"/>
                 <a:cs typeface="Calibri" panose="020F0502020204030204" pitchFamily="34" charset="0"/>
               </a:rPr>
-              <a:t>Arbitrary data types for </a:t>
-            </a:r>
-            <a:r>
-              <a:rPr lang="en-US" sz="1800" dirty="0" err="1">
-                <a:latin typeface="Calibri" panose="020F0502020204030204" pitchFamily="34" charset="0"/>
-                <a:ea typeface="Cambria Math" panose="02040503050406030204" pitchFamily="18" charset="0"/>
-                <a:cs typeface="Calibri" panose="020F0502020204030204" pitchFamily="34" charset="0"/>
-              </a:rPr>
-              <a:t>elemements</a:t>
-            </a:r>
-            <a:endParaRPr lang="en-US" sz="1800" dirty="0">
-              <a:latin typeface="Calibri" panose="020F0502020204030204" pitchFamily="34" charset="0"/>
-              <a:ea typeface="Cambria Math" panose="02040503050406030204" pitchFamily="18" charset="0"/>
-              <a:cs typeface="Calibri" panose="020F0502020204030204" pitchFamily="34" charset="0"/>
-            </a:endParaRPr>
+              <a:t>Arbitrary data types for elements</a:t>
+            </a:r>
           </a:p>
           <a:p>
             <a:pPr marL="285750" indent="-285750">
@@ -30666,8 +30668,8 @@
           </a:p>
         </p:txBody>
       </p:sp>
-      <mc:AlternateContent xmlns:mc="http://schemas.openxmlformats.org/markup-compatibility/2006">
-        <mc:Choice xmlns:a14="http://schemas.microsoft.com/office/drawing/2010/main" Requires="a14">
+      <mc:AlternateContent xmlns:mc="http://schemas.openxmlformats.org/markup-compatibility/2006" xmlns:a14="http://schemas.microsoft.com/office/drawing/2010/main">
+        <mc:Choice Requires="a14">
           <p:sp>
             <p:nvSpPr>
               <p:cNvPr id="8" name="Google Shape;87;p2">
@@ -32020,7 +32022,7 @@
             </p:txBody>
           </p:sp>
         </mc:Choice>
-        <mc:Fallback>
+        <mc:Fallback xmlns="">
           <p:sp>
             <p:nvSpPr>
               <p:cNvPr id="8" name="Google Shape;87;p2">
@@ -34962,8 +34964,8 @@
           </a:p>
         </p:txBody>
       </p:sp>
-      <mc:AlternateContent xmlns:mc="http://schemas.openxmlformats.org/markup-compatibility/2006">
-        <mc:Choice xmlns:a14="http://schemas.microsoft.com/office/drawing/2010/main" Requires="a14">
+      <mc:AlternateContent xmlns:mc="http://schemas.openxmlformats.org/markup-compatibility/2006" xmlns:a14="http://schemas.microsoft.com/office/drawing/2010/main">
+        <mc:Choice Requires="a14">
           <p:sp>
             <p:nvSpPr>
               <p:cNvPr id="8" name="Google Shape;87;p2">
@@ -36871,7 +36873,7 @@
             </p:txBody>
           </p:sp>
         </mc:Choice>
-        <mc:Fallback>
+        <mc:Fallback xmlns="">
           <p:sp>
             <p:nvSpPr>
               <p:cNvPr id="8" name="Google Shape;87;p2">
@@ -40782,6 +40784,48 @@
               <a:ea typeface="Cambria Math" panose="02040503050406030204" pitchFamily="18" charset="0"/>
               <a:cs typeface="Calibri" panose="020F0502020204030204" pitchFamily="34" charset="0"/>
             </a:endParaRPr>
+          </a:p>
+          <a:p>
+            <a:pPr marL="0" indent="0">
+              <a:spcBef>
+                <a:spcPts val="640"/>
+              </a:spcBef>
+            </a:pPr>
+            <a:endParaRPr lang="en-US" sz="1800" dirty="0">
+              <a:latin typeface="Calibri" panose="020F0502020204030204" pitchFamily="34" charset="0"/>
+              <a:ea typeface="Cambria Math" panose="02040503050406030204" pitchFamily="18" charset="0"/>
+              <a:cs typeface="Calibri" panose="020F0502020204030204" pitchFamily="34" charset="0"/>
+            </a:endParaRPr>
+          </a:p>
+          <a:p>
+            <a:pPr marL="0" indent="0">
+              <a:spcBef>
+                <a:spcPts val="640"/>
+              </a:spcBef>
+            </a:pPr>
+            <a:r>
+              <a:rPr lang="en-US" sz="1800" noProof="0" dirty="0">
+                <a:latin typeface="Calibri" panose="020F0502020204030204" pitchFamily="34" charset="0"/>
+                <a:ea typeface="Cambria Math" panose="02040503050406030204" pitchFamily="18" charset="0"/>
+                <a:cs typeface="Calibri" panose="020F0502020204030204" pitchFamily="34" charset="0"/>
+              </a:rPr>
+              <a:t>[‘red’, ‘green’, ‘blue’</a:t>
+            </a:r>
+            <a:br>
+              <a:rPr lang="en-US" sz="1800" noProof="0" dirty="0">
+                <a:latin typeface="Calibri" panose="020F0502020204030204" pitchFamily="34" charset="0"/>
+                <a:ea typeface="Cambria Math" panose="02040503050406030204" pitchFamily="18" charset="0"/>
+                <a:cs typeface="Calibri" panose="020F0502020204030204" pitchFamily="34" charset="0"/>
+              </a:rPr>
+            </a:br>
+            <a:r>
+              <a:rPr lang="en-US" sz="1800" noProof="0" dirty="0">
+                <a:latin typeface="Calibri" panose="020F0502020204030204" pitchFamily="34" charset="0"/>
+                <a:ea typeface="Cambria Math" panose="02040503050406030204" pitchFamily="18" charset="0"/>
+                <a:cs typeface="Calibri" panose="020F0502020204030204" pitchFamily="34" charset="0"/>
+              </a:rPr>
+              <a:t>    0         1            2</a:t>
+            </a:r>
           </a:p>
         </p:txBody>
       </p:sp>

</xml_diff>